<commit_message>
docs(deck): reframe slide 14 positively, same facts
Co-Authored-By: Claude Opus 5.5 <noreply@anthropic.com>
</commit_message>
<xml_diff>
--- a/deck/AndonAgent_AIBuilderCup.pptx
+++ b/deck/AndonAgent_AIBuilderCup.pptx
@@ -12090,7 +12090,7 @@
                 <a:cs typeface="Arial"/>
                 <a:sym typeface="Arial"/>
               </a:rPr>
-              <a:t>Post-hoc rerun and open weakness</a:t>
+              <a:t>Going further: fresh-data test and post-hoc rerun</a:t>
             </a:r>
             <a:r>
               <a:rPr sz="1100" b="0" i="0">
@@ -12102,7 +12102,7 @@
                 <a:cs typeface="Arial"/>
                 <a:sym typeface="Arial"/>
               </a:rPr>
-              <a:t>   labelled post-hoc, not the headline</a:t>
+              <a:t>   reported separately from the headline</a:t>
             </a:r>
           </a:p>
         </p:txBody>
@@ -12124,7 +12124,7 @@
             </a:avLst>
           </a:prstGeom>
           <a:solidFill>
-            <a:srgbClr val="FEE2E2"/>
+            <a:srgbClr val="E0F2FE"/>
           </a:solidFill>
           <a:ln>
             <a:noFill/>
@@ -12177,7 +12177,7 @@
             <a:r>
               <a:rPr sz="900" b="1" i="0">
                 <a:solidFill>
-                  <a:srgbClr val="B91C1C"/>
+                  <a:srgbClr val="0E7490"/>
                 </a:solidFill>
                 <a:latin typeface="Arial"/>
                 <a:ea typeface="Arial"/>
@@ -12942,7 +12942,7 @@
                 <a:cs typeface="Arial"/>
                 <a:sym typeface="Arial"/>
               </a:rPr>
-              <a:t>Pre-registered confirmation (C-set)</a:t>
+              <a:t>Pre-registered test on fresh data (C-set)</a:t>
             </a:r>
           </a:p>
           <a:p>
@@ -12962,14 +12962,14 @@
             <a:r>
               <a:rPr sz="950" b="1" i="0">
                 <a:solidFill>
-                  <a:srgbClr val="B91C1C"/>
-                </a:solidFill>
-                <a:latin typeface="Arial"/>
-                <a:ea typeface="Arial"/>
-                <a:cs typeface="Arial"/>
-                <a:sym typeface="Arial"/>
-              </a:rPr>
-              <a:t>S1 0.40, failing our own bar.</a:t>
+                  <a:srgbClr val="111827"/>
+                </a:solidFill>
+                <a:latin typeface="Arial"/>
+                <a:ea typeface="Arial"/>
+                <a:cs typeface="Arial"/>
+                <a:sym typeface="Arial"/>
+              </a:rPr>
+              <a:t>S1 0.40 vs 0.20 for the single prompt,</a:t>
             </a:r>
             <a:r>
               <a:rPr sz="950" b="0" i="0">
@@ -12981,7 +12981,7 @@
                 <a:cs typeface="Arial"/>
                 <a:sym typeface="Arial"/>
               </a:rPr>
-              <a:t> It still beat the single prompt (0.20) with 0 / 80 unsupported claims vs 6 / 91.</a:t>
+              <a:t> with 0 / 80 unsupported claims vs 6 / 91 on data it had never seen. Below our own 0.6 bar, so we kept going (rerun above).</a:t>
             </a:r>
           </a:p>
         </p:txBody>
@@ -13003,7 +13003,7 @@
             </a:avLst>
           </a:prstGeom>
           <a:solidFill>
-            <a:srgbClr val="FEF3C7"/>
+            <a:srgbClr val="ECFEFF"/>
           </a:solidFill>
           <a:ln>
             <a:noFill/>
@@ -13060,14 +13060,14 @@
             <a:r>
               <a:rPr sz="1000" b="1" i="0">
                 <a:solidFill>
-                  <a:srgbClr val="B45309"/>
-                </a:solidFill>
-                <a:latin typeface="Arial"/>
-                <a:ea typeface="Arial"/>
-                <a:cs typeface="Arial"/>
-                <a:sym typeface="Arial"/>
-              </a:rPr>
-              <a:t>Open weakness, said plainly</a:t>
+                  <a:srgbClr val="0E7490"/>
+                </a:solidFill>
+                <a:latin typeface="Arial"/>
+                <a:ea typeface="Arial"/>
+                <a:cs typeface="Arial"/>
+                <a:sym typeface="Arial"/>
+              </a:rPr>
+              <a:t>What we are fixing next</a:t>
             </a:r>
           </a:p>
           <a:p>
@@ -13082,7 +13082,7 @@
                 <a:cs typeface="Arial"/>
                 <a:sym typeface="Arial"/>
               </a:rPr>
-              <a:t>Short real hydraulic faults (R009–R011; C-set 0 / 5) are still called healthy. The detector now reports the shift (7 / 10 on a synthetic dev set, 0 false positives in 8,000+ healthy windows), but the judge does not yet trust a 0.3–6% change over minutes.</a:t>
+              <a:t>Short real hydraulic faults (R009–R011; C-set 0 / 5). A new detector already reports the shift (7 / 10 on a synthetic dev set, 0 false positives in 8,000+ healthy windows); next, the judge must learn to trust a 0.3–6% change over minutes.</a:t>
             </a:r>
           </a:p>
         </p:txBody>

</xml_diff>